<commit_message>
Bygg om PPT-mallen baserat pa sveland.se grafiska profil
Genererad med python-pptx i venv. Sveland-grön (#2E5B4F) som primarfarg,
mintgrön (#6FA68B) som accent, beige (#FAE6D2) for varma sektioner,
sans-serif typografi, rundade former och cirkeldekorationer som matchar
sveland.se. 5 layouts: titel, avsnittsskiljare, innehall (rubrik+bullets),
tvaspaltig, avslut.

Levererar bade .pptx (for demo B) och .potx (template-format) i ZIP.

Co-Authored-By: Claude Opus 4.7 (1M context) <noreply@anthropic.com>
</commit_message>
<xml_diff>
--- a/demomaterial/sveland-presentationsmall.pptx
+++ b/demomaterial/sveland-presentationsmall.pptx
@@ -5,16 +5,13 @@
     <p:sldMasterId id="2147483648" r:id="rId1"/>
   </p:sldMasterIdLst>
   <p:sldIdLst>
-    <p:sldId id="256" r:id="rId2"/>
-    <p:sldId id="257" r:id="rId3"/>
-    <p:sldId id="258" r:id="rId4"/>
-    <p:sldId id="259" r:id="rId5"/>
-    <p:sldId id="260" r:id="rId6"/>
-    <p:sldId id="261" r:id="rId7"/>
-    <p:sldId id="262" r:id="rId8"/>
-    <p:sldId id="263" r:id="rId9"/>
+    <p:sldId id="256" r:id="rId7"/>
+    <p:sldId id="257" r:id="rId8"/>
+    <p:sldId id="258" r:id="rId9"/>
+    <p:sldId id="259" r:id="rId10"/>
+    <p:sldId id="260" r:id="rId11"/>
   </p:sldIdLst>
-  <p:sldSz cx="9144000" cy="6858000" type="screen4x3"/>
+  <p:sldSz cx="12191695" cy="6858000" type="screen4x3"/>
   <p:notesSz cx="6858000" cy="9144000"/>
   <p:defaultTextStyle>
     <a:defPPr>
@@ -111,22 +108,6 @@
       </a:defRPr>
     </a:lvl9pPr>
   </p:defaultTextStyle>
-  <p:extLst>
-    <p:ext uri="{EFAFB233-063F-42B5-8137-9DF3F51BA10A}">
-      <p15:sldGuideLst xmlns:p15="http://schemas.microsoft.com/office/powerpoint/2012/main">
-        <p15:guide id="1" orient="horz" pos="2160">
-          <p15:clr>
-            <a:srgbClr val="A4A3A4"/>
-          </p15:clr>
-        </p15:guide>
-        <p15:guide id="2" pos="2880">
-          <p15:clr>
-            <a:srgbClr val="A4A3A4"/>
-          </p15:clr>
-        </p15:guide>
-      </p15:sldGuideLst>
-    </p:ext>
-  </p:extLst>
 </p:presentation>
 </file>
 
@@ -168,9 +149,10 @@
           <a:lstStyle/>
           <a:p>
             <a:r>
-              <a:rPr lang="en-US"/>
+              <a:rPr lang="en-US" smtClean="0"/>
               <a:t>Click to edit Master title style</a:t>
             </a:r>
+            <a:endParaRPr lang="en-US"/>
           </a:p>
         </p:txBody>
       </p:sp>
@@ -286,9 +268,10 @@
           </a:lstStyle>
           <a:p>
             <a:r>
-              <a:rPr lang="en-US"/>
+              <a:rPr lang="en-US" smtClean="0"/>
               <a:t>Click to edit Master subtitle style</a:t>
             </a:r>
+            <a:endParaRPr lang="en-US"/>
           </a:p>
         </p:txBody>
       </p:sp>
@@ -309,7 +292,7 @@
           <a:p>
             <a:fld id="{5BCAD085-E8A6-8845-BD4E-CB4CCA059FC4}" type="datetimeFigureOut">
               <a:rPr lang="en-US" smtClean="0"/>
-              <a:t>5/6/2026</a:t>
+              <a:t>1/27/13</a:t>
             </a:fld>
             <a:endParaRPr lang="en-US"/>
           </a:p>
@@ -403,9 +386,10 @@
           <a:lstStyle/>
           <a:p>
             <a:r>
-              <a:rPr lang="en-US"/>
+              <a:rPr lang="en-US" smtClean="0"/>
               <a:t>Click to edit Master title style</a:t>
             </a:r>
+            <a:endParaRPr lang="en-US"/>
           </a:p>
         </p:txBody>
       </p:sp>
@@ -426,37 +410,38 @@
           <a:p>
             <a:pPr lvl="0"/>
             <a:r>
-              <a:rPr lang="en-US"/>
+              <a:rPr lang="en-US" smtClean="0"/>
               <a:t>Click to edit Master text styles</a:t>
             </a:r>
           </a:p>
           <a:p>
             <a:pPr lvl="1"/>
             <a:r>
-              <a:rPr lang="en-US"/>
+              <a:rPr lang="en-US" smtClean="0"/>
               <a:t>Second level</a:t>
             </a:r>
           </a:p>
           <a:p>
             <a:pPr lvl="2"/>
             <a:r>
-              <a:rPr lang="en-US"/>
+              <a:rPr lang="en-US" smtClean="0"/>
               <a:t>Third level</a:t>
             </a:r>
           </a:p>
           <a:p>
             <a:pPr lvl="3"/>
             <a:r>
-              <a:rPr lang="en-US"/>
+              <a:rPr lang="en-US" smtClean="0"/>
               <a:t>Fourth level</a:t>
             </a:r>
           </a:p>
           <a:p>
             <a:pPr lvl="4"/>
             <a:r>
-              <a:rPr lang="en-US"/>
+              <a:rPr lang="en-US" smtClean="0"/>
               <a:t>Fifth level</a:t>
             </a:r>
+            <a:endParaRPr lang="en-US"/>
           </a:p>
         </p:txBody>
       </p:sp>
@@ -477,7 +462,7 @@
           <a:p>
             <a:fld id="{5BCAD085-E8A6-8845-BD4E-CB4CCA059FC4}" type="datetimeFigureOut">
               <a:rPr lang="en-US" smtClean="0"/>
-              <a:t>5/6/2026</a:t>
+              <a:t>1/27/13</a:t>
             </a:fld>
             <a:endParaRPr lang="en-US"/>
           </a:p>
@@ -576,9 +561,10 @@
           <a:lstStyle/>
           <a:p>
             <a:r>
-              <a:rPr lang="en-US"/>
+              <a:rPr lang="en-US" smtClean="0"/>
               <a:t>Click to edit Master title style</a:t>
             </a:r>
+            <a:endParaRPr lang="en-US"/>
           </a:p>
         </p:txBody>
       </p:sp>
@@ -604,37 +590,38 @@
           <a:p>
             <a:pPr lvl="0"/>
             <a:r>
-              <a:rPr lang="en-US"/>
+              <a:rPr lang="en-US" smtClean="0"/>
               <a:t>Click to edit Master text styles</a:t>
             </a:r>
           </a:p>
           <a:p>
             <a:pPr lvl="1"/>
             <a:r>
-              <a:rPr lang="en-US"/>
+              <a:rPr lang="en-US" smtClean="0"/>
               <a:t>Second level</a:t>
             </a:r>
           </a:p>
           <a:p>
             <a:pPr lvl="2"/>
             <a:r>
-              <a:rPr lang="en-US"/>
+              <a:rPr lang="en-US" smtClean="0"/>
               <a:t>Third level</a:t>
             </a:r>
           </a:p>
           <a:p>
             <a:pPr lvl="3"/>
             <a:r>
-              <a:rPr lang="en-US"/>
+              <a:rPr lang="en-US" smtClean="0"/>
               <a:t>Fourth level</a:t>
             </a:r>
           </a:p>
           <a:p>
             <a:pPr lvl="4"/>
             <a:r>
-              <a:rPr lang="en-US"/>
+              <a:rPr lang="en-US" smtClean="0"/>
               <a:t>Fifth level</a:t>
             </a:r>
+            <a:endParaRPr lang="en-US"/>
           </a:p>
         </p:txBody>
       </p:sp>
@@ -655,7 +642,7 @@
           <a:p>
             <a:fld id="{5BCAD085-E8A6-8845-BD4E-CB4CCA059FC4}" type="datetimeFigureOut">
               <a:rPr lang="en-US" smtClean="0"/>
-              <a:t>5/6/2026</a:t>
+              <a:t>1/27/13</a:t>
             </a:fld>
             <a:endParaRPr lang="en-US"/>
           </a:p>
@@ -749,9 +736,10 @@
           <a:lstStyle/>
           <a:p>
             <a:r>
-              <a:rPr lang="en-US"/>
+              <a:rPr lang="en-US" smtClean="0"/>
               <a:t>Click to edit Master title style</a:t>
             </a:r>
+            <a:endParaRPr lang="en-US"/>
           </a:p>
         </p:txBody>
       </p:sp>
@@ -772,37 +760,38 @@
           <a:p>
             <a:pPr lvl="0"/>
             <a:r>
-              <a:rPr lang="en-US"/>
+              <a:rPr lang="en-US" smtClean="0"/>
               <a:t>Click to edit Master text styles</a:t>
             </a:r>
           </a:p>
           <a:p>
             <a:pPr lvl="1"/>
             <a:r>
-              <a:rPr lang="en-US"/>
+              <a:rPr lang="en-US" smtClean="0"/>
               <a:t>Second level</a:t>
             </a:r>
           </a:p>
           <a:p>
             <a:pPr lvl="2"/>
             <a:r>
-              <a:rPr lang="en-US"/>
+              <a:rPr lang="en-US" smtClean="0"/>
               <a:t>Third level</a:t>
             </a:r>
           </a:p>
           <a:p>
             <a:pPr lvl="3"/>
             <a:r>
-              <a:rPr lang="en-US"/>
+              <a:rPr lang="en-US" smtClean="0"/>
               <a:t>Fourth level</a:t>
             </a:r>
           </a:p>
           <a:p>
             <a:pPr lvl="4"/>
             <a:r>
-              <a:rPr lang="en-US"/>
+              <a:rPr lang="en-US" smtClean="0"/>
               <a:t>Fifth level</a:t>
             </a:r>
+            <a:endParaRPr lang="en-US"/>
           </a:p>
         </p:txBody>
       </p:sp>
@@ -823,7 +812,7 @@
           <a:p>
             <a:fld id="{5BCAD085-E8A6-8845-BD4E-CB4CCA059FC4}" type="datetimeFigureOut">
               <a:rPr lang="en-US" smtClean="0"/>
-              <a:t>5/6/2026</a:t>
+              <a:t>1/27/13</a:t>
             </a:fld>
             <a:endParaRPr lang="en-US"/>
           </a:p>
@@ -926,9 +915,10 @@
           </a:lstStyle>
           <a:p>
             <a:r>
-              <a:rPr lang="en-US"/>
+              <a:rPr lang="en-US" smtClean="0"/>
               <a:t>Click to edit Master title style</a:t>
             </a:r>
+            <a:endParaRPr lang="en-US"/>
           </a:p>
         </p:txBody>
       </p:sp>
@@ -1045,7 +1035,7 @@
           <a:p>
             <a:pPr lvl="0"/>
             <a:r>
-              <a:rPr lang="en-US"/>
+              <a:rPr lang="en-US" smtClean="0"/>
               <a:t>Click to edit Master text styles</a:t>
             </a:r>
           </a:p>
@@ -1068,7 +1058,7 @@
           <a:p>
             <a:fld id="{5BCAD085-E8A6-8845-BD4E-CB4CCA059FC4}" type="datetimeFigureOut">
               <a:rPr lang="en-US" smtClean="0"/>
-              <a:t>5/6/2026</a:t>
+              <a:t>1/27/13</a:t>
             </a:fld>
             <a:endParaRPr lang="en-US"/>
           </a:p>
@@ -1162,9 +1152,10 @@
           <a:lstStyle/>
           <a:p>
             <a:r>
-              <a:rPr lang="en-US"/>
+              <a:rPr lang="en-US" smtClean="0"/>
               <a:t>Click to edit Master title style</a:t>
             </a:r>
+            <a:endParaRPr lang="en-US"/>
           </a:p>
         </p:txBody>
       </p:sp>
@@ -1218,37 +1209,38 @@
           <a:p>
             <a:pPr lvl="0"/>
             <a:r>
-              <a:rPr lang="en-US"/>
+              <a:rPr lang="en-US" smtClean="0"/>
               <a:t>Click to edit Master text styles</a:t>
             </a:r>
           </a:p>
           <a:p>
             <a:pPr lvl="1"/>
             <a:r>
-              <a:rPr lang="en-US"/>
+              <a:rPr lang="en-US" smtClean="0"/>
               <a:t>Second level</a:t>
             </a:r>
           </a:p>
           <a:p>
             <a:pPr lvl="2"/>
             <a:r>
-              <a:rPr lang="en-US"/>
+              <a:rPr lang="en-US" smtClean="0"/>
               <a:t>Third level</a:t>
             </a:r>
           </a:p>
           <a:p>
             <a:pPr lvl="3"/>
             <a:r>
-              <a:rPr lang="en-US"/>
+              <a:rPr lang="en-US" smtClean="0"/>
               <a:t>Fourth level</a:t>
             </a:r>
           </a:p>
           <a:p>
             <a:pPr lvl="4"/>
             <a:r>
-              <a:rPr lang="en-US"/>
+              <a:rPr lang="en-US" smtClean="0"/>
               <a:t>Fifth level</a:t>
             </a:r>
+            <a:endParaRPr lang="en-US"/>
           </a:p>
         </p:txBody>
       </p:sp>
@@ -1302,37 +1294,38 @@
           <a:p>
             <a:pPr lvl="0"/>
             <a:r>
-              <a:rPr lang="en-US"/>
+              <a:rPr lang="en-US" smtClean="0"/>
               <a:t>Click to edit Master text styles</a:t>
             </a:r>
           </a:p>
           <a:p>
             <a:pPr lvl="1"/>
             <a:r>
-              <a:rPr lang="en-US"/>
+              <a:rPr lang="en-US" smtClean="0"/>
               <a:t>Second level</a:t>
             </a:r>
           </a:p>
           <a:p>
             <a:pPr lvl="2"/>
             <a:r>
-              <a:rPr lang="en-US"/>
+              <a:rPr lang="en-US" smtClean="0"/>
               <a:t>Third level</a:t>
             </a:r>
           </a:p>
           <a:p>
             <a:pPr lvl="3"/>
             <a:r>
-              <a:rPr lang="en-US"/>
+              <a:rPr lang="en-US" smtClean="0"/>
               <a:t>Fourth level</a:t>
             </a:r>
           </a:p>
           <a:p>
             <a:pPr lvl="4"/>
             <a:r>
-              <a:rPr lang="en-US"/>
+              <a:rPr lang="en-US" smtClean="0"/>
               <a:t>Fifth level</a:t>
             </a:r>
+            <a:endParaRPr lang="en-US"/>
           </a:p>
         </p:txBody>
       </p:sp>
@@ -1353,7 +1346,7 @@
           <a:p>
             <a:fld id="{5BCAD085-E8A6-8845-BD4E-CB4CCA059FC4}" type="datetimeFigureOut">
               <a:rPr lang="en-US" smtClean="0"/>
-              <a:t>5/6/2026</a:t>
+              <a:t>1/27/13</a:t>
             </a:fld>
             <a:endParaRPr lang="en-US"/>
           </a:p>
@@ -1451,9 +1444,10 @@
           </a:lstStyle>
           <a:p>
             <a:r>
-              <a:rPr lang="en-US"/>
+              <a:rPr lang="en-US" smtClean="0"/>
               <a:t>Click to edit Master title style</a:t>
             </a:r>
+            <a:endParaRPr lang="en-US"/>
           </a:p>
         </p:txBody>
       </p:sp>
@@ -1516,7 +1510,7 @@
           <a:p>
             <a:pPr lvl="0"/>
             <a:r>
-              <a:rPr lang="en-US"/>
+              <a:rPr lang="en-US" smtClean="0"/>
               <a:t>Click to edit Master text styles</a:t>
             </a:r>
           </a:p>
@@ -1572,37 +1566,38 @@
           <a:p>
             <a:pPr lvl="0"/>
             <a:r>
-              <a:rPr lang="en-US"/>
+              <a:rPr lang="en-US" smtClean="0"/>
               <a:t>Click to edit Master text styles</a:t>
             </a:r>
           </a:p>
           <a:p>
             <a:pPr lvl="1"/>
             <a:r>
-              <a:rPr lang="en-US"/>
+              <a:rPr lang="en-US" smtClean="0"/>
               <a:t>Second level</a:t>
             </a:r>
           </a:p>
           <a:p>
             <a:pPr lvl="2"/>
             <a:r>
-              <a:rPr lang="en-US"/>
+              <a:rPr lang="en-US" smtClean="0"/>
               <a:t>Third level</a:t>
             </a:r>
           </a:p>
           <a:p>
             <a:pPr lvl="3"/>
             <a:r>
-              <a:rPr lang="en-US"/>
+              <a:rPr lang="en-US" smtClean="0"/>
               <a:t>Fourth level</a:t>
             </a:r>
           </a:p>
           <a:p>
             <a:pPr lvl="4"/>
             <a:r>
-              <a:rPr lang="en-US"/>
+              <a:rPr lang="en-US" smtClean="0"/>
               <a:t>Fifth level</a:t>
             </a:r>
+            <a:endParaRPr lang="en-US"/>
           </a:p>
         </p:txBody>
       </p:sp>
@@ -1665,7 +1660,7 @@
           <a:p>
             <a:pPr lvl="0"/>
             <a:r>
-              <a:rPr lang="en-US"/>
+              <a:rPr lang="en-US" smtClean="0"/>
               <a:t>Click to edit Master text styles</a:t>
             </a:r>
           </a:p>
@@ -1721,37 +1716,38 @@
           <a:p>
             <a:pPr lvl="0"/>
             <a:r>
-              <a:rPr lang="en-US"/>
+              <a:rPr lang="en-US" smtClean="0"/>
               <a:t>Click to edit Master text styles</a:t>
             </a:r>
           </a:p>
           <a:p>
             <a:pPr lvl="1"/>
             <a:r>
-              <a:rPr lang="en-US"/>
+              <a:rPr lang="en-US" smtClean="0"/>
               <a:t>Second level</a:t>
             </a:r>
           </a:p>
           <a:p>
             <a:pPr lvl="2"/>
             <a:r>
-              <a:rPr lang="en-US"/>
+              <a:rPr lang="en-US" smtClean="0"/>
               <a:t>Third level</a:t>
             </a:r>
           </a:p>
           <a:p>
             <a:pPr lvl="3"/>
             <a:r>
-              <a:rPr lang="en-US"/>
+              <a:rPr lang="en-US" smtClean="0"/>
               <a:t>Fourth level</a:t>
             </a:r>
           </a:p>
           <a:p>
             <a:pPr lvl="4"/>
             <a:r>
-              <a:rPr lang="en-US"/>
+              <a:rPr lang="en-US" smtClean="0"/>
               <a:t>Fifth level</a:t>
             </a:r>
+            <a:endParaRPr lang="en-US"/>
           </a:p>
         </p:txBody>
       </p:sp>
@@ -1772,7 +1768,7 @@
           <a:p>
             <a:fld id="{5BCAD085-E8A6-8845-BD4E-CB4CCA059FC4}" type="datetimeFigureOut">
               <a:rPr lang="en-US" smtClean="0"/>
-              <a:t>5/6/2026</a:t>
+              <a:t>1/27/13</a:t>
             </a:fld>
             <a:endParaRPr lang="en-US"/>
           </a:p>
@@ -1866,9 +1862,10 @@
           <a:lstStyle/>
           <a:p>
             <a:r>
-              <a:rPr lang="en-US"/>
+              <a:rPr lang="en-US" smtClean="0"/>
               <a:t>Click to edit Master title style</a:t>
             </a:r>
+            <a:endParaRPr lang="en-US"/>
           </a:p>
         </p:txBody>
       </p:sp>
@@ -1889,7 +1886,7 @@
           <a:p>
             <a:fld id="{5BCAD085-E8A6-8845-BD4E-CB4CCA059FC4}" type="datetimeFigureOut">
               <a:rPr lang="en-US" smtClean="0"/>
-              <a:t>5/6/2026</a:t>
+              <a:t>1/27/13</a:t>
             </a:fld>
             <a:endParaRPr lang="en-US"/>
           </a:p>
@@ -1984,7 +1981,7 @@
           <a:p>
             <a:fld id="{5BCAD085-E8A6-8845-BD4E-CB4CCA059FC4}" type="datetimeFigureOut">
               <a:rPr lang="en-US" smtClean="0"/>
-              <a:t>5/6/2026</a:t>
+              <a:t>1/27/13</a:t>
             </a:fld>
             <a:endParaRPr lang="en-US"/>
           </a:p>
@@ -2087,9 +2084,10 @@
           </a:lstStyle>
           <a:p>
             <a:r>
-              <a:rPr lang="en-US"/>
+              <a:rPr lang="en-US" smtClean="0"/>
               <a:t>Click to edit Master title style</a:t>
             </a:r>
+            <a:endParaRPr lang="en-US"/>
           </a:p>
         </p:txBody>
       </p:sp>
@@ -2143,37 +2141,38 @@
           <a:p>
             <a:pPr lvl="0"/>
             <a:r>
-              <a:rPr lang="en-US"/>
+              <a:rPr lang="en-US" smtClean="0"/>
               <a:t>Click to edit Master text styles</a:t>
             </a:r>
           </a:p>
           <a:p>
             <a:pPr lvl="1"/>
             <a:r>
-              <a:rPr lang="en-US"/>
+              <a:rPr lang="en-US" smtClean="0"/>
               <a:t>Second level</a:t>
             </a:r>
           </a:p>
           <a:p>
             <a:pPr lvl="2"/>
             <a:r>
-              <a:rPr lang="en-US"/>
+              <a:rPr lang="en-US" smtClean="0"/>
               <a:t>Third level</a:t>
             </a:r>
           </a:p>
           <a:p>
             <a:pPr lvl="3"/>
             <a:r>
-              <a:rPr lang="en-US"/>
+              <a:rPr lang="en-US" smtClean="0"/>
               <a:t>Fourth level</a:t>
             </a:r>
           </a:p>
           <a:p>
             <a:pPr lvl="4"/>
             <a:r>
-              <a:rPr lang="en-US"/>
+              <a:rPr lang="en-US" smtClean="0"/>
               <a:t>Fifth level</a:t>
             </a:r>
+            <a:endParaRPr lang="en-US"/>
           </a:p>
         </p:txBody>
       </p:sp>
@@ -2236,7 +2235,7 @@
           <a:p>
             <a:pPr lvl="0"/>
             <a:r>
-              <a:rPr lang="en-US"/>
+              <a:rPr lang="en-US" smtClean="0"/>
               <a:t>Click to edit Master text styles</a:t>
             </a:r>
           </a:p>
@@ -2259,7 +2258,7 @@
           <a:p>
             <a:fld id="{5BCAD085-E8A6-8845-BD4E-CB4CCA059FC4}" type="datetimeFigureOut">
               <a:rPr lang="en-US" smtClean="0"/>
-              <a:t>5/6/2026</a:t>
+              <a:t>1/27/13</a:t>
             </a:fld>
             <a:endParaRPr lang="en-US"/>
           </a:p>
@@ -2362,9 +2361,10 @@
           </a:lstStyle>
           <a:p>
             <a:r>
-              <a:rPr lang="en-US"/>
+              <a:rPr lang="en-US" smtClean="0"/>
               <a:t>Click to edit Master title style</a:t>
             </a:r>
+            <a:endParaRPr lang="en-US"/>
           </a:p>
         </p:txBody>
       </p:sp>
@@ -2488,7 +2488,7 @@
           <a:p>
             <a:pPr lvl="0"/>
             <a:r>
-              <a:rPr lang="en-US"/>
+              <a:rPr lang="en-US" smtClean="0"/>
               <a:t>Click to edit Master text styles</a:t>
             </a:r>
           </a:p>
@@ -2511,7 +2511,7 @@
           <a:p>
             <a:fld id="{5BCAD085-E8A6-8845-BD4E-CB4CCA059FC4}" type="datetimeFigureOut">
               <a:rPr lang="en-US" smtClean="0"/>
-              <a:t>5/6/2026</a:t>
+              <a:t>1/27/13</a:t>
             </a:fld>
             <a:endParaRPr lang="en-US"/>
           </a:p>
@@ -2620,9 +2620,10 @@
           <a:lstStyle/>
           <a:p>
             <a:r>
-              <a:rPr lang="en-US"/>
+              <a:rPr lang="en-US" smtClean="0"/>
               <a:t>Click to edit Master title style</a:t>
             </a:r>
+            <a:endParaRPr lang="en-US"/>
           </a:p>
         </p:txBody>
       </p:sp>
@@ -2653,37 +2654,38 @@
           <a:p>
             <a:pPr lvl="0"/>
             <a:r>
-              <a:rPr lang="en-US"/>
+              <a:rPr lang="en-US" smtClean="0"/>
               <a:t>Click to edit Master text styles</a:t>
             </a:r>
           </a:p>
           <a:p>
             <a:pPr lvl="1"/>
             <a:r>
-              <a:rPr lang="en-US"/>
+              <a:rPr lang="en-US" smtClean="0"/>
               <a:t>Second level</a:t>
             </a:r>
           </a:p>
           <a:p>
             <a:pPr lvl="2"/>
             <a:r>
-              <a:rPr lang="en-US"/>
+              <a:rPr lang="en-US" smtClean="0"/>
               <a:t>Third level</a:t>
             </a:r>
           </a:p>
           <a:p>
             <a:pPr lvl="3"/>
             <a:r>
-              <a:rPr lang="en-US"/>
+              <a:rPr lang="en-US" smtClean="0"/>
               <a:t>Fourth level</a:t>
             </a:r>
           </a:p>
           <a:p>
             <a:pPr lvl="4"/>
             <a:r>
-              <a:rPr lang="en-US"/>
+              <a:rPr lang="en-US" smtClean="0"/>
               <a:t>Fifth level</a:t>
             </a:r>
+            <a:endParaRPr lang="en-US"/>
           </a:p>
         </p:txBody>
       </p:sp>
@@ -2722,7 +2724,7 @@
           <a:p>
             <a:fld id="{5BCAD085-E8A6-8845-BD4E-CB4CCA059FC4}" type="datetimeFigureOut">
               <a:rPr lang="en-US" smtClean="0"/>
-              <a:t>5/6/2026</a:t>
+              <a:t>1/27/13</a:t>
             </a:fld>
             <a:endParaRPr lang="en-US"/>
           </a:p>
@@ -3081,82 +3083,288 @@
 </file>
 
 <file path=ppt/slides/slide1.xml><?xml version="1.0" encoding="utf-8"?>
-<p:sld xmlns:a="http://schemas.openxmlformats.org/drawingml/2006/main" xmlns:r="http://schemas.openxmlformats.org/officeDocument/2006/relationships" xmlns:p="http://schemas.openxmlformats.org/presentationml/2006/main">
+<p:sld xmlns:a="http://schemas.openxmlformats.org/drawingml/2006/main" xmlns:p="http://schemas.openxmlformats.org/presentationml/2006/main" xmlns:r="http://schemas.openxmlformats.org/officeDocument/2006/relationships">
   <p:cSld>
-    <p:bg>
-      <p:bgPr>
-        <a:solidFill>
-          <a:srgbClr val="FFF6F0"/>
-        </a:solidFill>
-        <a:effectLst/>
-      </p:bgPr>
-    </p:bg>
     <p:spTree>
       <p:nvGrpSpPr>
         <p:cNvPr id="1" name=""/>
         <p:cNvGrpSpPr/>
         <p:nvPr/>
       </p:nvGrpSpPr>
-      <p:grpSpPr>
-        <a:xfrm>
-          <a:off x="0" y="0"/>
-          <a:ext cx="0" cy="0"/>
-          <a:chOff x="0" y="0"/>
-          <a:chExt cx="0" cy="0"/>
-        </a:xfrm>
-      </p:grpSpPr>
-      <p:sp>
-        <p:nvSpPr>
-          <p:cNvPr id="2" name="Title 1"/>
-          <p:cNvSpPr>
-            <a:spLocks noGrp="1"/>
-          </p:cNvSpPr>
-          <p:nvPr>
-            <p:ph type="ctrTitle"/>
-          </p:nvPr>
-        </p:nvSpPr>
-        <p:spPr/>
-        <p:txBody>
-          <a:bodyPr/>
-          <a:lstStyle/>
-          <a:p>
-            <a:pPr algn="l">
-              <a:defRPr sz="4000" b="1">
+      <p:grpSpPr/>
+      <p:sp>
+        <p:nvSpPr>
+          <p:cNvPr id="2" name="Rectangle 1"/>
+          <p:cNvSpPr/>
+          <p:nvPr/>
+        </p:nvSpPr>
+        <p:spPr>
+          <a:xfrm>
+            <a:off x="0" y="0"/>
+            <a:ext cx="12191695" cy="6858000"/>
+          </a:xfrm>
+          <a:prstGeom prst="rect">
+            <a:avLst/>
+          </a:prstGeom>
+          <a:solidFill>
+            <a:srgbClr val="FAE6D2"/>
+          </a:solidFill>
+          <a:ln>
+            <a:noFill/>
+          </a:ln>
+        </p:spPr>
+        <p:style>
+          <a:lnRef idx="1">
+            <a:schemeClr val="accent1"/>
+          </a:lnRef>
+          <a:fillRef idx="3">
+            <a:schemeClr val="accent1"/>
+          </a:fillRef>
+          <a:effectRef idx="2">
+            <a:schemeClr val="accent1"/>
+          </a:effectRef>
+          <a:fontRef idx="minor">
+            <a:schemeClr val="lt1"/>
+          </a:fontRef>
+        </p:style>
+        <p:txBody>
+          <a:bodyPr rtlCol="0" anchor="ctr"/>
+          <a:lstStyle/>
+          <a:p>
+            <a:pPr algn="ctr"/>
+          </a:p>
+        </p:txBody>
+      </p:sp>
+      <p:sp>
+        <p:nvSpPr>
+          <p:cNvPr id="3" name="Oval 2"/>
+          <p:cNvSpPr/>
+          <p:nvPr/>
+        </p:nvSpPr>
+        <p:spPr>
+          <a:xfrm>
+            <a:off x="10515600" y="-1371600"/>
+            <a:ext cx="3200400" cy="3200400"/>
+          </a:xfrm>
+          <a:prstGeom prst="ellipse">
+            <a:avLst/>
+          </a:prstGeom>
+          <a:solidFill>
+            <a:srgbClr val="6FA68B"/>
+          </a:solidFill>
+          <a:ln>
+            <a:noFill/>
+          </a:ln>
+        </p:spPr>
+        <p:style>
+          <a:lnRef idx="1">
+            <a:schemeClr val="accent1"/>
+          </a:lnRef>
+          <a:fillRef idx="3">
+            <a:schemeClr val="accent1"/>
+          </a:fillRef>
+          <a:effectRef idx="2">
+            <a:schemeClr val="accent1"/>
+          </a:effectRef>
+          <a:fontRef idx="minor">
+            <a:schemeClr val="lt1"/>
+          </a:fontRef>
+        </p:style>
+        <p:txBody>
+          <a:bodyPr rtlCol="0" anchor="ctr"/>
+          <a:lstStyle/>
+          <a:p>
+            <a:pPr algn="ctr"/>
+          </a:p>
+        </p:txBody>
+      </p:sp>
+      <p:sp>
+        <p:nvSpPr>
+          <p:cNvPr id="4" name="Oval 3"/>
+          <p:cNvSpPr/>
+          <p:nvPr/>
+        </p:nvSpPr>
+        <p:spPr>
+          <a:xfrm>
+            <a:off x="11247120" y="365760"/>
+            <a:ext cx="1828800" cy="1828800"/>
+          </a:xfrm>
+          <a:prstGeom prst="ellipse">
+            <a:avLst/>
+          </a:prstGeom>
+          <a:solidFill>
+            <a:srgbClr val="2E5B4F"/>
+          </a:solidFill>
+          <a:ln>
+            <a:noFill/>
+          </a:ln>
+        </p:spPr>
+        <p:style>
+          <a:lnRef idx="1">
+            <a:schemeClr val="accent1"/>
+          </a:lnRef>
+          <a:fillRef idx="3">
+            <a:schemeClr val="accent1"/>
+          </a:fillRef>
+          <a:effectRef idx="2">
+            <a:schemeClr val="accent1"/>
+          </a:effectRef>
+          <a:fontRef idx="minor">
+            <a:schemeClr val="lt1"/>
+          </a:fontRef>
+        </p:style>
+        <p:txBody>
+          <a:bodyPr rtlCol="0" anchor="ctr"/>
+          <a:lstStyle/>
+          <a:p>
+            <a:pPr algn="ctr"/>
+          </a:p>
+        </p:txBody>
+      </p:sp>
+      <p:sp>
+        <p:nvSpPr>
+          <p:cNvPr id="5" name="Oval 4"/>
+          <p:cNvSpPr/>
+          <p:nvPr/>
+        </p:nvSpPr>
+        <p:spPr>
+          <a:xfrm>
+            <a:off x="-457200" y="5669280"/>
+            <a:ext cx="1463040" cy="1463040"/>
+          </a:xfrm>
+          <a:prstGeom prst="ellipse">
+            <a:avLst/>
+          </a:prstGeom>
+          <a:solidFill>
+            <a:srgbClr val="2E5B4F"/>
+          </a:solidFill>
+          <a:ln>
+            <a:noFill/>
+          </a:ln>
+        </p:spPr>
+        <p:style>
+          <a:lnRef idx="1">
+            <a:schemeClr val="accent1"/>
+          </a:lnRef>
+          <a:fillRef idx="3">
+            <a:schemeClr val="accent1"/>
+          </a:fillRef>
+          <a:effectRef idx="2">
+            <a:schemeClr val="accent1"/>
+          </a:effectRef>
+          <a:fontRef idx="minor">
+            <a:schemeClr val="lt1"/>
+          </a:fontRef>
+        </p:style>
+        <p:txBody>
+          <a:bodyPr rtlCol="0" anchor="ctr"/>
+          <a:lstStyle/>
+          <a:p>
+            <a:pPr algn="ctr"/>
+          </a:p>
+        </p:txBody>
+      </p:sp>
+      <p:sp>
+        <p:nvSpPr>
+          <p:cNvPr id="6" name="TextBox 5"/>
+          <p:cNvSpPr txBox="1"/>
+          <p:nvPr/>
+        </p:nvSpPr>
+        <p:spPr>
+          <a:xfrm>
+            <a:off x="822960" y="2377440"/>
+            <a:ext cx="10058400" cy="1463040"/>
+          </a:xfrm>
+          <a:prstGeom prst="rect">
+            <a:avLst/>
+          </a:prstGeom>
+          <a:noFill/>
+        </p:spPr>
+        <p:txBody>
+          <a:bodyPr wrap="square" anchor="t" lIns="0" rIns="0">
+            <a:spAutoFit/>
+          </a:bodyPr>
+          <a:lstStyle/>
+          <a:p>
+            <a:pPr algn="l"/>
+            <a:r>
+              <a:rPr sz="5400" b="1">
                 <a:solidFill>
                   <a:srgbClr val="2E5B4F"/>
                 </a:solidFill>
-              </a:defRPr>
-            </a:pPr>
-            <a:r>
-              <a:t>Rubrik – Sveland</a:t>
-            </a:r>
-          </a:p>
-        </p:txBody>
-      </p:sp>
-      <p:sp>
-        <p:nvSpPr>
-          <p:cNvPr id="3" name="Subtitle 2"/>
-          <p:cNvSpPr>
-            <a:spLocks noGrp="1"/>
-          </p:cNvSpPr>
-          <p:nvPr>
-            <p:ph type="subTitle" idx="1"/>
-          </p:nvPr>
-        </p:nvSpPr>
-        <p:spPr/>
-        <p:txBody>
-          <a:bodyPr/>
-          <a:lstStyle/>
-          <a:p>
-            <a:pPr>
-              <a:defRPr sz="2000">
+                <a:latin typeface="Calibri"/>
+              </a:rPr>
+              <a:t>Presentationstitel</a:t>
+            </a:r>
+          </a:p>
+        </p:txBody>
+      </p:sp>
+      <p:sp>
+        <p:nvSpPr>
+          <p:cNvPr id="7" name="TextBox 6"/>
+          <p:cNvSpPr txBox="1"/>
+          <p:nvPr/>
+        </p:nvSpPr>
+        <p:spPr>
+          <a:xfrm>
+            <a:off x="822960" y="3931920"/>
+            <a:ext cx="10058400" cy="548640"/>
+          </a:xfrm>
+          <a:prstGeom prst="rect">
+            <a:avLst/>
+          </a:prstGeom>
+          <a:noFill/>
+        </p:spPr>
+        <p:txBody>
+          <a:bodyPr wrap="square" anchor="t" lIns="0" rIns="0">
+            <a:spAutoFit/>
+          </a:bodyPr>
+          <a:lstStyle/>
+          <a:p>
+            <a:pPr algn="l"/>
+            <a:r>
+              <a:rPr sz="2200" b="0">
                 <a:solidFill>
-                  <a:srgbClr val="411B38"/>
+                  <a:srgbClr val="1A3D33"/>
                 </a:solidFill>
-              </a:defRPr>
-            </a:pPr>
-            <a:r>
-              <a:t>Underrubrik / beskrivning</a:t>
+                <a:latin typeface="Calibri"/>
+              </a:rPr>
+              <a:t>Underrubrik eller kort beskrivning</a:t>
+            </a:r>
+          </a:p>
+        </p:txBody>
+      </p:sp>
+      <p:sp>
+        <p:nvSpPr>
+          <p:cNvPr id="8" name="TextBox 7"/>
+          <p:cNvSpPr txBox="1"/>
+          <p:nvPr/>
+        </p:nvSpPr>
+        <p:spPr>
+          <a:xfrm>
+            <a:off x="822960" y="5760720"/>
+            <a:ext cx="10058400" cy="365760"/>
+          </a:xfrm>
+          <a:prstGeom prst="rect">
+            <a:avLst/>
+          </a:prstGeom>
+          <a:noFill/>
+        </p:spPr>
+        <p:txBody>
+          <a:bodyPr wrap="square" anchor="t" lIns="0" rIns="0">
+            <a:spAutoFit/>
+          </a:bodyPr>
+          <a:lstStyle/>
+          <a:p>
+            <a:pPr algn="l"/>
+            <a:r>
+              <a:rPr sz="1200" b="0">
+                <a:solidFill>
+                  <a:srgbClr val="333333"/>
+                </a:solidFill>
+                <a:latin typeface="Calibri"/>
+              </a:rPr>
+              <a:t>Sveland Djurförsäkring  •  Datum  •  Avsändare</a:t>
             </a:r>
           </a:p>
         </p:txBody>
@@ -3170,7 +3378,7 @@
 </file>
 
 <file path=ppt/slides/slide2.xml><?xml version="1.0" encoding="utf-8"?>
-<p:sld xmlns:a="http://schemas.openxmlformats.org/drawingml/2006/main" xmlns:r="http://schemas.openxmlformats.org/officeDocument/2006/relationships" xmlns:p="http://schemas.openxmlformats.org/presentationml/2006/main">
+<p:sld xmlns:a="http://schemas.openxmlformats.org/drawingml/2006/main" xmlns:p="http://schemas.openxmlformats.org/presentationml/2006/main" xmlns:r="http://schemas.openxmlformats.org/officeDocument/2006/relationships">
   <p:cSld>
     <p:spTree>
       <p:nvGrpSpPr>
@@ -3178,66 +3386,194 @@
         <p:cNvGrpSpPr/>
         <p:nvPr/>
       </p:nvGrpSpPr>
-      <p:grpSpPr>
-        <a:xfrm>
-          <a:off x="0" y="0"/>
-          <a:ext cx="0" cy="0"/>
-          <a:chOff x="0" y="0"/>
-          <a:chExt cx="0" cy="0"/>
-        </a:xfrm>
-      </p:grpSpPr>
-      <p:sp>
-        <p:nvSpPr>
-          <p:cNvPr id="2" name="Title 1"/>
-          <p:cNvSpPr>
-            <a:spLocks noGrp="1"/>
-          </p:cNvSpPr>
-          <p:nvPr>
-            <p:ph type="title"/>
-          </p:nvPr>
-        </p:nvSpPr>
-        <p:spPr/>
-        <p:txBody>
-          <a:bodyPr/>
-          <a:lstStyle/>
-          <a:p>
-            <a:pPr>
-              <a:defRPr sz="2800" b="1">
+      <p:grpSpPr/>
+      <p:sp>
+        <p:nvSpPr>
+          <p:cNvPr id="2" name="Rectangle 1"/>
+          <p:cNvSpPr/>
+          <p:nvPr/>
+        </p:nvSpPr>
+        <p:spPr>
+          <a:xfrm>
+            <a:off x="0" y="0"/>
+            <a:ext cx="12191695" cy="6858000"/>
+          </a:xfrm>
+          <a:prstGeom prst="rect">
+            <a:avLst/>
+          </a:prstGeom>
+          <a:solidFill>
+            <a:srgbClr val="2E5B4F"/>
+          </a:solidFill>
+          <a:ln>
+            <a:noFill/>
+          </a:ln>
+        </p:spPr>
+        <p:style>
+          <a:lnRef idx="1">
+            <a:schemeClr val="accent1"/>
+          </a:lnRef>
+          <a:fillRef idx="3">
+            <a:schemeClr val="accent1"/>
+          </a:fillRef>
+          <a:effectRef idx="2">
+            <a:schemeClr val="accent1"/>
+          </a:effectRef>
+          <a:fontRef idx="minor">
+            <a:schemeClr val="lt1"/>
+          </a:fontRef>
+        </p:style>
+        <p:txBody>
+          <a:bodyPr rtlCol="0" anchor="ctr"/>
+          <a:lstStyle/>
+          <a:p>
+            <a:pPr algn="ctr"/>
+          </a:p>
+        </p:txBody>
+      </p:sp>
+      <p:sp>
+        <p:nvSpPr>
+          <p:cNvPr id="3" name="Oval 2"/>
+          <p:cNvSpPr/>
+          <p:nvPr/>
+        </p:nvSpPr>
+        <p:spPr>
+          <a:xfrm>
+            <a:off x="-1828800" y="-1828800"/>
+            <a:ext cx="4572000" cy="4572000"/>
+          </a:xfrm>
+          <a:prstGeom prst="ellipse">
+            <a:avLst/>
+          </a:prstGeom>
+          <a:solidFill>
+            <a:srgbClr val="6FA68B"/>
+          </a:solidFill>
+          <a:ln>
+            <a:noFill/>
+          </a:ln>
+        </p:spPr>
+        <p:style>
+          <a:lnRef idx="1">
+            <a:schemeClr val="accent1"/>
+          </a:lnRef>
+          <a:fillRef idx="3">
+            <a:schemeClr val="accent1"/>
+          </a:fillRef>
+          <a:effectRef idx="2">
+            <a:schemeClr val="accent1"/>
+          </a:effectRef>
+          <a:fontRef idx="minor">
+            <a:schemeClr val="lt1"/>
+          </a:fontRef>
+        </p:style>
+        <p:txBody>
+          <a:bodyPr rtlCol="0" anchor="ctr"/>
+          <a:lstStyle/>
+          <a:p>
+            <a:pPr algn="ctr"/>
+          </a:p>
+        </p:txBody>
+      </p:sp>
+      <p:sp>
+        <p:nvSpPr>
+          <p:cNvPr id="4" name="TextBox 3"/>
+          <p:cNvSpPr txBox="1"/>
+          <p:nvPr/>
+        </p:nvSpPr>
+        <p:spPr>
+          <a:xfrm>
+            <a:off x="822960" y="1828800"/>
+            <a:ext cx="10058400" cy="457200"/>
+          </a:xfrm>
+          <a:prstGeom prst="rect">
+            <a:avLst/>
+          </a:prstGeom>
+          <a:noFill/>
+        </p:spPr>
+        <p:txBody>
+          <a:bodyPr wrap="square" anchor="t" lIns="0" rIns="0">
+            <a:spAutoFit/>
+          </a:bodyPr>
+          <a:lstStyle/>
+          <a:p>
+            <a:pPr algn="l"/>
+            <a:r>
+              <a:rPr sz="1400" b="1">
                 <a:solidFill>
-                  <a:srgbClr val="2E5B4F"/>
+                  <a:srgbClr val="6FA68B"/>
                 </a:solidFill>
-              </a:defRPr>
-            </a:pPr>
-            <a:r>
-              <a:t>Slide‑rubrik</a:t>
-            </a:r>
-          </a:p>
-        </p:txBody>
-      </p:sp>
-      <p:sp>
-        <p:nvSpPr>
-          <p:cNvPr id="3" name="Content Placeholder 2"/>
-          <p:cNvSpPr>
-            <a:spLocks noGrp="1"/>
-          </p:cNvSpPr>
-          <p:nvPr>
-            <p:ph idx="1"/>
-          </p:nvPr>
-        </p:nvSpPr>
-        <p:spPr/>
-        <p:txBody>
-          <a:bodyPr/>
-          <a:lstStyle/>
-          <a:p>
-            <a:pPr>
-              <a:defRPr sz="1600">
+                <a:latin typeface="Calibri"/>
+              </a:rPr>
+              <a:t>AVSNITT</a:t>
+            </a:r>
+          </a:p>
+        </p:txBody>
+      </p:sp>
+      <p:sp>
+        <p:nvSpPr>
+          <p:cNvPr id="5" name="TextBox 4"/>
+          <p:cNvSpPr txBox="1"/>
+          <p:nvPr/>
+        </p:nvSpPr>
+        <p:spPr>
+          <a:xfrm>
+            <a:off x="822960" y="2468880"/>
+            <a:ext cx="10058400" cy="2286000"/>
+          </a:xfrm>
+          <a:prstGeom prst="rect">
+            <a:avLst/>
+          </a:prstGeom>
+          <a:noFill/>
+        </p:spPr>
+        <p:txBody>
+          <a:bodyPr wrap="square" anchor="t" lIns="0" rIns="0">
+            <a:spAutoFit/>
+          </a:bodyPr>
+          <a:lstStyle/>
+          <a:p>
+            <a:pPr algn="l"/>
+            <a:r>
+              <a:rPr sz="6000" b="1">
                 <a:solidFill>
-                  <a:srgbClr val="411B38"/>
+                  <a:srgbClr val="FFFFFF"/>
                 </a:solidFill>
-              </a:defRPr>
-            </a:pPr>
-            <a:r>
-              <a:t>• Kärnbudskap</a:t>
+                <a:latin typeface="Calibri"/>
+              </a:rPr>
+              <a:t>Avsnittsrubrik</a:t>
+            </a:r>
+          </a:p>
+        </p:txBody>
+      </p:sp>
+      <p:sp>
+        <p:nvSpPr>
+          <p:cNvPr id="6" name="TextBox 5"/>
+          <p:cNvSpPr txBox="1"/>
+          <p:nvPr/>
+        </p:nvSpPr>
+        <p:spPr>
+          <a:xfrm>
+            <a:off x="822960" y="4572000"/>
+            <a:ext cx="10058400" cy="914400"/>
+          </a:xfrm>
+          <a:prstGeom prst="rect">
+            <a:avLst/>
+          </a:prstGeom>
+          <a:noFill/>
+        </p:spPr>
+        <p:txBody>
+          <a:bodyPr wrap="square" anchor="t" lIns="0" rIns="0">
+            <a:spAutoFit/>
+          </a:bodyPr>
+          <a:lstStyle/>
+          <a:p>
+            <a:pPr algn="l"/>
+            <a:r>
+              <a:rPr sz="2000" b="0">
+                <a:solidFill>
+                  <a:srgbClr val="FAE6D2"/>
+                </a:solidFill>
+                <a:latin typeface="Calibri"/>
+              </a:rPr>
+              <a:t>Kort beskrivning av vad detta avsnitt handlar om.</a:t>
             </a:r>
           </a:p>
         </p:txBody>
@@ -3251,82 +3587,289 @@
 </file>
 
 <file path=ppt/slides/slide3.xml><?xml version="1.0" encoding="utf-8"?>
-<p:sld xmlns:a="http://schemas.openxmlformats.org/drawingml/2006/main" xmlns:r="http://schemas.openxmlformats.org/officeDocument/2006/relationships" xmlns:p="http://schemas.openxmlformats.org/presentationml/2006/main">
+<p:sld xmlns:a="http://schemas.openxmlformats.org/drawingml/2006/main" xmlns:p="http://schemas.openxmlformats.org/presentationml/2006/main" xmlns:r="http://schemas.openxmlformats.org/officeDocument/2006/relationships">
   <p:cSld>
-    <p:bg>
-      <p:bgPr>
-        <a:solidFill>
-          <a:srgbClr val="FAE6D2"/>
-        </a:solidFill>
-        <a:effectLst/>
-      </p:bgPr>
-    </p:bg>
     <p:spTree>
       <p:nvGrpSpPr>
         <p:cNvPr id="1" name=""/>
         <p:cNvGrpSpPr/>
         <p:nvPr/>
       </p:nvGrpSpPr>
-      <p:grpSpPr>
-        <a:xfrm>
-          <a:off x="0" y="0"/>
-          <a:ext cx="0" cy="0"/>
-          <a:chOff x="0" y="0"/>
-          <a:chExt cx="0" cy="0"/>
-        </a:xfrm>
-      </p:grpSpPr>
-      <p:sp>
-        <p:nvSpPr>
-          <p:cNvPr id="2" name="Title 1"/>
-          <p:cNvSpPr>
-            <a:spLocks noGrp="1"/>
-          </p:cNvSpPr>
-          <p:nvPr>
-            <p:ph type="title"/>
-          </p:nvPr>
-        </p:nvSpPr>
-        <p:spPr/>
-        <p:txBody>
-          <a:bodyPr/>
-          <a:lstStyle/>
-          <a:p>
-            <a:pPr>
-              <a:defRPr sz="2800" b="1">
+      <p:grpSpPr/>
+      <p:sp>
+        <p:nvSpPr>
+          <p:cNvPr id="2" name="Rectangle 1"/>
+          <p:cNvSpPr/>
+          <p:nvPr/>
+        </p:nvSpPr>
+        <p:spPr>
+          <a:xfrm>
+            <a:off x="0" y="0"/>
+            <a:ext cx="12191695" cy="137160"/>
+          </a:xfrm>
+          <a:prstGeom prst="rect">
+            <a:avLst/>
+          </a:prstGeom>
+          <a:solidFill>
+            <a:srgbClr val="2E5B4F"/>
+          </a:solidFill>
+          <a:ln>
+            <a:noFill/>
+          </a:ln>
+        </p:spPr>
+        <p:style>
+          <a:lnRef idx="1">
+            <a:schemeClr val="accent1"/>
+          </a:lnRef>
+          <a:fillRef idx="3">
+            <a:schemeClr val="accent1"/>
+          </a:fillRef>
+          <a:effectRef idx="2">
+            <a:schemeClr val="accent1"/>
+          </a:effectRef>
+          <a:fontRef idx="minor">
+            <a:schemeClr val="lt1"/>
+          </a:fontRef>
+        </p:style>
+        <p:txBody>
+          <a:bodyPr rtlCol="0" anchor="ctr"/>
+          <a:lstStyle/>
+          <a:p>
+            <a:pPr algn="ctr"/>
+          </a:p>
+        </p:txBody>
+      </p:sp>
+      <p:sp>
+        <p:nvSpPr>
+          <p:cNvPr id="3" name="TextBox 2"/>
+          <p:cNvSpPr txBox="1"/>
+          <p:nvPr/>
+        </p:nvSpPr>
+        <p:spPr>
+          <a:xfrm>
+            <a:off x="822960" y="548640"/>
+            <a:ext cx="10515600" cy="914400"/>
+          </a:xfrm>
+          <a:prstGeom prst="rect">
+            <a:avLst/>
+          </a:prstGeom>
+          <a:noFill/>
+        </p:spPr>
+        <p:txBody>
+          <a:bodyPr wrap="square" anchor="t" lIns="0" rIns="0">
+            <a:spAutoFit/>
+          </a:bodyPr>
+          <a:lstStyle/>
+          <a:p>
+            <a:pPr algn="l"/>
+            <a:r>
+              <a:rPr sz="3600" b="1">
                 <a:solidFill>
                   <a:srgbClr val="2E5B4F"/>
                 </a:solidFill>
-              </a:defRPr>
+                <a:latin typeface="Calibri"/>
+              </a:rPr>
+              <a:t>Rubrik på innehållssliden</a:t>
+            </a:r>
+          </a:p>
+        </p:txBody>
+      </p:sp>
+      <p:sp>
+        <p:nvSpPr>
+          <p:cNvPr id="4" name="TextBox 3"/>
+          <p:cNvSpPr txBox="1"/>
+          <p:nvPr/>
+        </p:nvSpPr>
+        <p:spPr>
+          <a:xfrm>
+            <a:off x="822960" y="1554480"/>
+            <a:ext cx="10515600" cy="457200"/>
+          </a:xfrm>
+          <a:prstGeom prst="rect">
+            <a:avLst/>
+          </a:prstGeom>
+          <a:noFill/>
+        </p:spPr>
+        <p:txBody>
+          <a:bodyPr wrap="square" anchor="t" lIns="0" rIns="0">
+            <a:spAutoFit/>
+          </a:bodyPr>
+          <a:lstStyle/>
+          <a:p>
+            <a:pPr algn="l"/>
+            <a:r>
+              <a:rPr sz="1600" b="0">
+                <a:solidFill>
+                  <a:srgbClr val="333333"/>
+                </a:solidFill>
+                <a:latin typeface="Calibri"/>
+              </a:rPr>
+              <a:t>En kort underrubrik som ramar in innehållet nedan.</a:t>
+            </a:r>
+          </a:p>
+        </p:txBody>
+      </p:sp>
+      <p:sp>
+        <p:nvSpPr>
+          <p:cNvPr id="5" name="TextBox 4"/>
+          <p:cNvSpPr txBox="1"/>
+          <p:nvPr/>
+        </p:nvSpPr>
+        <p:spPr>
+          <a:xfrm>
+            <a:off x="822960" y="2286000"/>
+            <a:ext cx="10515600" cy="3657600"/>
+          </a:xfrm>
+          <a:prstGeom prst="rect">
+            <a:avLst/>
+          </a:prstGeom>
+          <a:noFill/>
+        </p:spPr>
+        <p:txBody>
+          <a:bodyPr wrap="square">
+            <a:spAutoFit/>
+          </a:bodyPr>
+          <a:lstStyle/>
+          <a:p>
+            <a:pPr algn="l">
+              <a:spcAft>
+                <a:spcPts val="1200"/>
+              </a:spcAft>
             </a:pPr>
             <a:r>
-              <a:t>Rekommenderad riktning</a:t>
-            </a:r>
-          </a:p>
-        </p:txBody>
-      </p:sp>
-      <p:sp>
-        <p:nvSpPr>
-          <p:cNvPr id="3" name="Content Placeholder 2"/>
-          <p:cNvSpPr>
-            <a:spLocks noGrp="1"/>
-          </p:cNvSpPr>
-          <p:nvPr>
-            <p:ph idx="1"/>
-          </p:nvPr>
-        </p:nvSpPr>
-        <p:spPr/>
-        <p:txBody>
-          <a:bodyPr/>
-          <a:lstStyle/>
-          <a:p>
-            <a:pPr>
-              <a:defRPr sz="1600">
+              <a:rPr sz="2000">
                 <a:solidFill>
-                  <a:srgbClr val="411B38"/>
+                  <a:srgbClr val="333333"/>
                 </a:solidFill>
-              </a:defRPr>
+                <a:latin typeface="Calibri"/>
+              </a:rPr>
+              <a:t>•  Första punkten — håll dem korta och konkreta.</a:t>
+            </a:r>
+          </a:p>
+          <a:p>
+            <a:pPr algn="l">
+              <a:spcAft>
+                <a:spcPts val="1200"/>
+              </a:spcAft>
             </a:pPr>
             <a:r>
-              <a:t>• Fokuserat nästa steg</a:t>
+              <a:rPr sz="2000">
+                <a:solidFill>
+                  <a:srgbClr val="333333"/>
+                </a:solidFill>
+                <a:latin typeface="Calibri"/>
+              </a:rPr>
+              <a:t>•  Andra punkten — max 5 ord per punkt om du kan.</a:t>
+            </a:r>
+          </a:p>
+          <a:p>
+            <a:pPr algn="l">
+              <a:spcAft>
+                <a:spcPts val="1200"/>
+              </a:spcAft>
+            </a:pPr>
+            <a:r>
+              <a:rPr sz="2000">
+                <a:solidFill>
+                  <a:srgbClr val="333333"/>
+                </a:solidFill>
+                <a:latin typeface="Calibri"/>
+              </a:rPr>
+              <a:t>•  Tredje punkten — luftigt mellanrum mellan raderna.</a:t>
+            </a:r>
+          </a:p>
+          <a:p>
+            <a:pPr algn="l">
+              <a:spcAft>
+                <a:spcPts val="1200"/>
+              </a:spcAft>
+            </a:pPr>
+            <a:r>
+              <a:rPr sz="2000">
+                <a:solidFill>
+                  <a:srgbClr val="333333"/>
+                </a:solidFill>
+                <a:latin typeface="Calibri"/>
+              </a:rPr>
+              <a:t>•  Fjärde punkten — gärna med en handling eller insikt.</a:t>
+            </a:r>
+          </a:p>
+        </p:txBody>
+      </p:sp>
+      <p:sp>
+        <p:nvSpPr>
+          <p:cNvPr id="6" name="Rectangle 5"/>
+          <p:cNvSpPr/>
+          <p:nvPr/>
+        </p:nvSpPr>
+        <p:spPr>
+          <a:xfrm>
+            <a:off x="0" y="6492240"/>
+            <a:ext cx="12191695" cy="365760"/>
+          </a:xfrm>
+          <a:prstGeom prst="rect">
+            <a:avLst/>
+          </a:prstGeom>
+          <a:solidFill>
+            <a:srgbClr val="FAE6D2"/>
+          </a:solidFill>
+          <a:ln>
+            <a:noFill/>
+          </a:ln>
+        </p:spPr>
+        <p:style>
+          <a:lnRef idx="1">
+            <a:schemeClr val="accent1"/>
+          </a:lnRef>
+          <a:fillRef idx="3">
+            <a:schemeClr val="accent1"/>
+          </a:fillRef>
+          <a:effectRef idx="2">
+            <a:schemeClr val="accent1"/>
+          </a:effectRef>
+          <a:fontRef idx="minor">
+            <a:schemeClr val="lt1"/>
+          </a:fontRef>
+        </p:style>
+        <p:txBody>
+          <a:bodyPr rtlCol="0" anchor="ctr"/>
+          <a:lstStyle/>
+          <a:p>
+            <a:pPr algn="ctr"/>
+          </a:p>
+        </p:txBody>
+      </p:sp>
+      <p:sp>
+        <p:nvSpPr>
+          <p:cNvPr id="7" name="TextBox 6"/>
+          <p:cNvSpPr txBox="1"/>
+          <p:nvPr/>
+        </p:nvSpPr>
+        <p:spPr>
+          <a:xfrm>
+            <a:off x="822960" y="6528816"/>
+            <a:ext cx="10515600" cy="292608"/>
+          </a:xfrm>
+          <a:prstGeom prst="rect">
+            <a:avLst/>
+          </a:prstGeom>
+          <a:noFill/>
+        </p:spPr>
+        <p:txBody>
+          <a:bodyPr wrap="square" anchor="ctr" lIns="0" rIns="0">
+            <a:spAutoFit/>
+          </a:bodyPr>
+          <a:lstStyle/>
+          <a:p>
+            <a:pPr algn="l"/>
+            <a:r>
+              <a:rPr sz="1000" b="0">
+                <a:solidFill>
+                  <a:srgbClr val="2E5B4F"/>
+                </a:solidFill>
+                <a:latin typeface="Calibri"/>
+              </a:rPr>
+              <a:t>Sveland Djurförsäkring</a:t>
             </a:r>
           </a:p>
         </p:txBody>
@@ -3340,7 +3883,7 @@
 </file>
 
 <file path=ppt/slides/slide4.xml><?xml version="1.0" encoding="utf-8"?>
-<p:sld xmlns:a="http://schemas.openxmlformats.org/drawingml/2006/main" xmlns:r="http://schemas.openxmlformats.org/officeDocument/2006/relationships" xmlns:p="http://schemas.openxmlformats.org/presentationml/2006/main">
+<p:sld xmlns:a="http://schemas.openxmlformats.org/drawingml/2006/main" xmlns:p="http://schemas.openxmlformats.org/presentationml/2006/main" xmlns:r="http://schemas.openxmlformats.org/officeDocument/2006/relationships">
   <p:cSld>
     <p:spTree>
       <p:nvGrpSpPr>
@@ -3348,62 +3891,377 @@
         <p:cNvGrpSpPr/>
         <p:nvPr/>
       </p:nvGrpSpPr>
-      <p:grpSpPr>
-        <a:xfrm>
-          <a:off x="0" y="0"/>
-          <a:ext cx="0" cy="0"/>
-          <a:chOff x="0" y="0"/>
-          <a:chExt cx="0" cy="0"/>
-        </a:xfrm>
-      </p:grpSpPr>
-      <p:sp>
-        <p:nvSpPr>
-          <p:cNvPr id="2" name="Title 1"/>
-          <p:cNvSpPr>
-            <a:spLocks noGrp="1"/>
-          </p:cNvSpPr>
-          <p:nvPr>
-            <p:ph type="title"/>
-          </p:nvPr>
-        </p:nvSpPr>
-        <p:spPr/>
-        <p:txBody>
-          <a:bodyPr/>
-          <a:lstStyle/>
-          <a:p>
-            <a:r>
-              <a:t>Q1 skador – snabbt läge</a:t>
-            </a:r>
-          </a:p>
-        </p:txBody>
-      </p:sp>
-      <p:sp>
-        <p:nvSpPr>
-          <p:cNvPr id="3" name="Content Placeholder 2"/>
-          <p:cNvSpPr>
-            <a:spLocks noGrp="1"/>
-          </p:cNvSpPr>
-          <p:nvPr>
-            <p:ph idx="1"/>
-          </p:nvPr>
-        </p:nvSpPr>
-        <p:spPr/>
-        <p:txBody>
-          <a:bodyPr/>
-          <a:lstStyle/>
-          <a:p>
-            <a:r>
-              <a:t>30 skadeärenden under Q1</a:t>
-            </a:r>
-          </a:p>
-          <a:p>
-            <a:r>
-              <a:t>Ersättning ca 321 tkr</a:t>
-            </a:r>
-          </a:p>
-          <a:p>
-            <a:r>
-              <a:t>Utfallet drivs av få, kostsamma ärenden</a:t>
+      <p:grpSpPr/>
+      <p:sp>
+        <p:nvSpPr>
+          <p:cNvPr id="2" name="Rectangle 1"/>
+          <p:cNvSpPr/>
+          <p:nvPr/>
+        </p:nvSpPr>
+        <p:spPr>
+          <a:xfrm>
+            <a:off x="0" y="0"/>
+            <a:ext cx="12191695" cy="137160"/>
+          </a:xfrm>
+          <a:prstGeom prst="rect">
+            <a:avLst/>
+          </a:prstGeom>
+          <a:solidFill>
+            <a:srgbClr val="2E5B4F"/>
+          </a:solidFill>
+          <a:ln>
+            <a:noFill/>
+          </a:ln>
+        </p:spPr>
+        <p:style>
+          <a:lnRef idx="1">
+            <a:schemeClr val="accent1"/>
+          </a:lnRef>
+          <a:fillRef idx="3">
+            <a:schemeClr val="accent1"/>
+          </a:fillRef>
+          <a:effectRef idx="2">
+            <a:schemeClr val="accent1"/>
+          </a:effectRef>
+          <a:fontRef idx="minor">
+            <a:schemeClr val="lt1"/>
+          </a:fontRef>
+        </p:style>
+        <p:txBody>
+          <a:bodyPr rtlCol="0" anchor="ctr"/>
+          <a:lstStyle/>
+          <a:p>
+            <a:pPr algn="ctr"/>
+          </a:p>
+        </p:txBody>
+      </p:sp>
+      <p:sp>
+        <p:nvSpPr>
+          <p:cNvPr id="3" name="TextBox 2"/>
+          <p:cNvSpPr txBox="1"/>
+          <p:nvPr/>
+        </p:nvSpPr>
+        <p:spPr>
+          <a:xfrm>
+            <a:off x="822960" y="548640"/>
+            <a:ext cx="10515600" cy="914400"/>
+          </a:xfrm>
+          <a:prstGeom prst="rect">
+            <a:avLst/>
+          </a:prstGeom>
+          <a:noFill/>
+        </p:spPr>
+        <p:txBody>
+          <a:bodyPr wrap="square" anchor="t" lIns="0" rIns="0">
+            <a:spAutoFit/>
+          </a:bodyPr>
+          <a:lstStyle/>
+          <a:p>
+            <a:pPr algn="l"/>
+            <a:r>
+              <a:rPr sz="3600" b="1">
+                <a:solidFill>
+                  <a:srgbClr val="2E5B4F"/>
+                </a:solidFill>
+                <a:latin typeface="Calibri"/>
+              </a:rPr>
+              <a:t>Tvåspaltig layout</a:t>
+            </a:r>
+          </a:p>
+        </p:txBody>
+      </p:sp>
+      <p:sp>
+        <p:nvSpPr>
+          <p:cNvPr id="4" name="Rounded Rectangle 3"/>
+          <p:cNvSpPr/>
+          <p:nvPr/>
+        </p:nvSpPr>
+        <p:spPr>
+          <a:xfrm>
+            <a:off x="822960" y="1828800"/>
+            <a:ext cx="5120640" cy="4114800"/>
+          </a:xfrm>
+          <a:prstGeom prst="roundRect">
+            <a:avLst/>
+          </a:prstGeom>
+          <a:solidFill>
+            <a:srgbClr val="FAE6D2"/>
+          </a:solidFill>
+          <a:ln>
+            <a:noFill/>
+          </a:ln>
+        </p:spPr>
+        <p:style>
+          <a:lnRef idx="1">
+            <a:schemeClr val="accent1"/>
+          </a:lnRef>
+          <a:fillRef idx="3">
+            <a:schemeClr val="accent1"/>
+          </a:fillRef>
+          <a:effectRef idx="2">
+            <a:schemeClr val="accent1"/>
+          </a:effectRef>
+          <a:fontRef idx="minor">
+            <a:schemeClr val="lt1"/>
+          </a:fontRef>
+        </p:style>
+        <p:txBody>
+          <a:bodyPr rtlCol="0" anchor="ctr"/>
+          <a:lstStyle/>
+          <a:p>
+            <a:pPr algn="ctr"/>
+          </a:p>
+        </p:txBody>
+      </p:sp>
+      <p:sp>
+        <p:nvSpPr>
+          <p:cNvPr id="5" name="TextBox 4"/>
+          <p:cNvSpPr txBox="1"/>
+          <p:nvPr/>
+        </p:nvSpPr>
+        <p:spPr>
+          <a:xfrm>
+            <a:off x="1097280" y="2103120"/>
+            <a:ext cx="4572000" cy="457200"/>
+          </a:xfrm>
+          <a:prstGeom prst="rect">
+            <a:avLst/>
+          </a:prstGeom>
+          <a:noFill/>
+        </p:spPr>
+        <p:txBody>
+          <a:bodyPr wrap="square" anchor="t" lIns="0" rIns="0">
+            <a:spAutoFit/>
+          </a:bodyPr>
+          <a:lstStyle/>
+          <a:p>
+            <a:pPr algn="l"/>
+            <a:r>
+              <a:rPr sz="1200" b="1">
+                <a:solidFill>
+                  <a:srgbClr val="2E5B4F"/>
+                </a:solidFill>
+                <a:latin typeface="Calibri"/>
+              </a:rPr>
+              <a:t>VÄNSTER KOLUMN</a:t>
+            </a:r>
+          </a:p>
+        </p:txBody>
+      </p:sp>
+      <p:sp>
+        <p:nvSpPr>
+          <p:cNvPr id="6" name="TextBox 5"/>
+          <p:cNvSpPr txBox="1"/>
+          <p:nvPr/>
+        </p:nvSpPr>
+        <p:spPr>
+          <a:xfrm>
+            <a:off x="1097280" y="2651760"/>
+            <a:ext cx="4572000" cy="640080"/>
+          </a:xfrm>
+          <a:prstGeom prst="rect">
+            <a:avLst/>
+          </a:prstGeom>
+          <a:noFill/>
+        </p:spPr>
+        <p:txBody>
+          <a:bodyPr wrap="square" anchor="t" lIns="0" rIns="0">
+            <a:spAutoFit/>
+          </a:bodyPr>
+          <a:lstStyle/>
+          <a:p>
+            <a:pPr algn="l"/>
+            <a:r>
+              <a:rPr sz="2400" b="1">
+                <a:solidFill>
+                  <a:srgbClr val="1A3D33"/>
+                </a:solidFill>
+                <a:latin typeface="Calibri"/>
+              </a:rPr>
+              <a:t>Tema eller insikt</a:t>
+            </a:r>
+          </a:p>
+        </p:txBody>
+      </p:sp>
+      <p:sp>
+        <p:nvSpPr>
+          <p:cNvPr id="7" name="TextBox 6"/>
+          <p:cNvSpPr txBox="1"/>
+          <p:nvPr/>
+        </p:nvSpPr>
+        <p:spPr>
+          <a:xfrm>
+            <a:off x="1097280" y="3474720"/>
+            <a:ext cx="4572000" cy="2286000"/>
+          </a:xfrm>
+          <a:prstGeom prst="rect">
+            <a:avLst/>
+          </a:prstGeom>
+          <a:noFill/>
+        </p:spPr>
+        <p:txBody>
+          <a:bodyPr wrap="square" anchor="t" lIns="0" rIns="0">
+            <a:spAutoFit/>
+          </a:bodyPr>
+          <a:lstStyle/>
+          <a:p>
+            <a:pPr algn="l"/>
+            <a:r>
+              <a:rPr sz="1500" b="0">
+                <a:solidFill>
+                  <a:srgbClr val="333333"/>
+                </a:solidFill>
+                <a:latin typeface="Calibri"/>
+              </a:rPr>
+              <a:t>Beskrivande text. Sveland-tonen är varm och rak. Skriv som någon som faktiskt bryr sig.</a:t>
+            </a:r>
+          </a:p>
+        </p:txBody>
+      </p:sp>
+      <p:sp>
+        <p:nvSpPr>
+          <p:cNvPr id="8" name="Rounded Rectangle 7"/>
+          <p:cNvSpPr/>
+          <p:nvPr/>
+        </p:nvSpPr>
+        <p:spPr>
+          <a:xfrm>
+            <a:off x="6217920" y="1828800"/>
+            <a:ext cx="5120640" cy="4114800"/>
+          </a:xfrm>
+          <a:prstGeom prst="roundRect">
+            <a:avLst/>
+          </a:prstGeom>
+          <a:solidFill>
+            <a:srgbClr val="2E5B4F"/>
+          </a:solidFill>
+          <a:ln>
+            <a:noFill/>
+          </a:ln>
+        </p:spPr>
+        <p:style>
+          <a:lnRef idx="1">
+            <a:schemeClr val="accent1"/>
+          </a:lnRef>
+          <a:fillRef idx="3">
+            <a:schemeClr val="accent1"/>
+          </a:fillRef>
+          <a:effectRef idx="2">
+            <a:schemeClr val="accent1"/>
+          </a:effectRef>
+          <a:fontRef idx="minor">
+            <a:schemeClr val="lt1"/>
+          </a:fontRef>
+        </p:style>
+        <p:txBody>
+          <a:bodyPr rtlCol="0" anchor="ctr"/>
+          <a:lstStyle/>
+          <a:p>
+            <a:pPr algn="ctr"/>
+          </a:p>
+        </p:txBody>
+      </p:sp>
+      <p:sp>
+        <p:nvSpPr>
+          <p:cNvPr id="9" name="TextBox 8"/>
+          <p:cNvSpPr txBox="1"/>
+          <p:nvPr/>
+        </p:nvSpPr>
+        <p:spPr>
+          <a:xfrm>
+            <a:off x="6492240" y="2103120"/>
+            <a:ext cx="4572000" cy="457200"/>
+          </a:xfrm>
+          <a:prstGeom prst="rect">
+            <a:avLst/>
+          </a:prstGeom>
+          <a:noFill/>
+        </p:spPr>
+        <p:txBody>
+          <a:bodyPr wrap="square" anchor="t" lIns="0" rIns="0">
+            <a:spAutoFit/>
+          </a:bodyPr>
+          <a:lstStyle/>
+          <a:p>
+            <a:pPr algn="l"/>
+            <a:r>
+              <a:rPr sz="1200" b="1">
+                <a:solidFill>
+                  <a:srgbClr val="6FA68B"/>
+                </a:solidFill>
+                <a:latin typeface="Calibri"/>
+              </a:rPr>
+              <a:t>HÖGER KOLUMN</a:t>
+            </a:r>
+          </a:p>
+        </p:txBody>
+      </p:sp>
+      <p:sp>
+        <p:nvSpPr>
+          <p:cNvPr id="10" name="TextBox 9"/>
+          <p:cNvSpPr txBox="1"/>
+          <p:nvPr/>
+        </p:nvSpPr>
+        <p:spPr>
+          <a:xfrm>
+            <a:off x="6492240" y="2651760"/>
+            <a:ext cx="4572000" cy="640080"/>
+          </a:xfrm>
+          <a:prstGeom prst="rect">
+            <a:avLst/>
+          </a:prstGeom>
+          <a:noFill/>
+        </p:spPr>
+        <p:txBody>
+          <a:bodyPr wrap="square" anchor="t" lIns="0" rIns="0">
+            <a:spAutoFit/>
+          </a:bodyPr>
+          <a:lstStyle/>
+          <a:p>
+            <a:pPr algn="l"/>
+            <a:r>
+              <a:rPr sz="2400" b="1">
+                <a:solidFill>
+                  <a:srgbClr val="FFFFFF"/>
+                </a:solidFill>
+                <a:latin typeface="Calibri"/>
+              </a:rPr>
+              <a:t>Tema eller insikt</a:t>
+            </a:r>
+          </a:p>
+        </p:txBody>
+      </p:sp>
+      <p:sp>
+        <p:nvSpPr>
+          <p:cNvPr id="11" name="TextBox 10"/>
+          <p:cNvSpPr txBox="1"/>
+          <p:nvPr/>
+        </p:nvSpPr>
+        <p:spPr>
+          <a:xfrm>
+            <a:off x="6492240" y="3474720"/>
+            <a:ext cx="4572000" cy="2286000"/>
+          </a:xfrm>
+          <a:prstGeom prst="rect">
+            <a:avLst/>
+          </a:prstGeom>
+          <a:noFill/>
+        </p:spPr>
+        <p:txBody>
+          <a:bodyPr wrap="square" anchor="t" lIns="0" rIns="0">
+            <a:spAutoFit/>
+          </a:bodyPr>
+          <a:lstStyle/>
+          <a:p>
+            <a:pPr algn="l"/>
+            <a:r>
+              <a:rPr sz="1500" b="0">
+                <a:solidFill>
+                  <a:srgbClr val="FAE6D2"/>
+                </a:solidFill>
+                <a:latin typeface="Calibri"/>
+              </a:rPr>
+              <a:t>Använd det här kortet för att framhäva en motpoäng eller en avslutande tanke.</a:t>
             </a:r>
           </a:p>
         </p:txBody>
@@ -3417,7 +4275,7 @@
 </file>
 
 <file path=ppt/slides/slide5.xml><?xml version="1.0" encoding="utf-8"?>
-<p:sld xmlns:a="http://schemas.openxmlformats.org/drawingml/2006/main" xmlns:r="http://schemas.openxmlformats.org/officeDocument/2006/relationships" xmlns:p="http://schemas.openxmlformats.org/presentationml/2006/main">
+<p:sld xmlns:a="http://schemas.openxmlformats.org/drawingml/2006/main" xmlns:p="http://schemas.openxmlformats.org/presentationml/2006/main" xmlns:r="http://schemas.openxmlformats.org/officeDocument/2006/relationships">
   <p:cSld>
     <p:spTree>
       <p:nvGrpSpPr>
@@ -3425,293 +4283,237 @@
         <p:cNvGrpSpPr/>
         <p:nvPr/>
       </p:nvGrpSpPr>
-      <p:grpSpPr>
-        <a:xfrm>
-          <a:off x="0" y="0"/>
-          <a:ext cx="0" cy="0"/>
-          <a:chOff x="0" y="0"/>
-          <a:chExt cx="0" cy="0"/>
-        </a:xfrm>
-      </p:grpSpPr>
-      <p:sp>
-        <p:nvSpPr>
-          <p:cNvPr id="2" name="Title 1"/>
-          <p:cNvSpPr>
-            <a:spLocks noGrp="1"/>
-          </p:cNvSpPr>
-          <p:nvPr>
-            <p:ph type="title"/>
-          </p:nvPr>
-        </p:nvSpPr>
-        <p:spPr/>
-        <p:txBody>
-          <a:bodyPr/>
-          <a:lstStyle/>
-          <a:p>
-            <a:r>
-              <a:t>Häst: låg volym, stor påverkan</a:t>
-            </a:r>
-          </a:p>
-        </p:txBody>
-      </p:sp>
-      <p:sp>
-        <p:nvSpPr>
-          <p:cNvPr id="3" name="Content Placeholder 2"/>
-          <p:cNvSpPr>
-            <a:spLocks noGrp="1"/>
-          </p:cNvSpPr>
-          <p:nvPr>
-            <p:ph idx="1"/>
-          </p:nvPr>
-        </p:nvSpPr>
-        <p:spPr/>
-        <p:txBody>
-          <a:bodyPr/>
-          <a:lstStyle/>
-          <a:p>
-            <a:r>
-              <a:t>6 av 30 ärenden</a:t>
-            </a:r>
-          </a:p>
-          <a:p>
-            <a:r>
-              <a:t>Ca 152 tkr – nästan hälften av total ersättning</a:t>
-            </a:r>
-          </a:p>
-          <a:p>
-            <a:r>
-              <a:t>Små förändringar ger stor effekt</a:t>
-            </a:r>
-          </a:p>
-        </p:txBody>
-      </p:sp>
-    </p:spTree>
-  </p:cSld>
-  <p:clrMapOvr>
-    <a:masterClrMapping/>
-  </p:clrMapOvr>
-</p:sld>
-</file>
-
-<file path=ppt/slides/slide6.xml><?xml version="1.0" encoding="utf-8"?>
-<p:sld xmlns:a="http://schemas.openxmlformats.org/drawingml/2006/main" xmlns:r="http://schemas.openxmlformats.org/officeDocument/2006/relationships" xmlns:p="http://schemas.openxmlformats.org/presentationml/2006/main">
-  <p:cSld>
-    <p:spTree>
-      <p:nvGrpSpPr>
-        <p:cNvPr id="1" name=""/>
-        <p:cNvGrpSpPr/>
-        <p:nvPr/>
-      </p:nvGrpSpPr>
-      <p:grpSpPr>
-        <a:xfrm>
-          <a:off x="0" y="0"/>
-          <a:ext cx="0" cy="0"/>
-          <a:chOff x="0" y="0"/>
-          <a:chExt cx="0" cy="0"/>
-        </a:xfrm>
-      </p:grpSpPr>
-      <p:sp>
-        <p:nvSpPr>
-          <p:cNvPr id="2" name="Title 1"/>
-          <p:cNvSpPr>
-            <a:spLocks noGrp="1"/>
-          </p:cNvSpPr>
-          <p:nvPr>
-            <p:ph type="title"/>
-          </p:nvPr>
-        </p:nvSpPr>
-        <p:spPr/>
-        <p:txBody>
-          <a:bodyPr/>
-          <a:lstStyle/>
-          <a:p>
-            <a:r>
-              <a:t>Operationer driver kostnad</a:t>
-            </a:r>
-          </a:p>
-        </p:txBody>
-      </p:sp>
-      <p:sp>
-        <p:nvSpPr>
-          <p:cNvPr id="3" name="Content Placeholder 2"/>
-          <p:cNvSpPr>
-            <a:spLocks noGrp="1"/>
-          </p:cNvSpPr>
-          <p:nvPr>
-            <p:ph idx="1"/>
-          </p:nvPr>
-        </p:nvSpPr>
-        <p:spPr/>
-        <p:txBody>
-          <a:bodyPr/>
-          <a:lstStyle/>
-          <a:p>
-            <a:r>
-              <a:t>Ca 159 tkr (≈ 50 % av ersättningen)</a:t>
-            </a:r>
-          </a:p>
-          <a:p>
-            <a:r>
-              <a:t>Enskilda beslut avgör utfallet</a:t>
-            </a:r>
-          </a:p>
-          <a:p>
-            <a:r>
-              <a:t>Viktigaste kategorin att följa</a:t>
-            </a:r>
-          </a:p>
-        </p:txBody>
-      </p:sp>
-    </p:spTree>
-  </p:cSld>
-  <p:clrMapOvr>
-    <a:masterClrMapping/>
-  </p:clrMapOvr>
-</p:sld>
-</file>
-
-<file path=ppt/slides/slide7.xml><?xml version="1.0" encoding="utf-8"?>
-<p:sld xmlns:a="http://schemas.openxmlformats.org/drawingml/2006/main" xmlns:r="http://schemas.openxmlformats.org/officeDocument/2006/relationships" xmlns:p="http://schemas.openxmlformats.org/presentationml/2006/main">
-  <p:cSld>
-    <p:spTree>
-      <p:nvGrpSpPr>
-        <p:cNvPr id="1" name=""/>
-        <p:cNvGrpSpPr/>
-        <p:nvPr/>
-      </p:nvGrpSpPr>
-      <p:grpSpPr>
-        <a:xfrm>
-          <a:off x="0" y="0"/>
-          <a:ext cx="0" cy="0"/>
-          <a:chOff x="0" y="0"/>
-          <a:chExt cx="0" cy="0"/>
-        </a:xfrm>
-      </p:grpSpPr>
-      <p:sp>
-        <p:nvSpPr>
-          <p:cNvPr id="2" name="Title 1"/>
-          <p:cNvSpPr>
-            <a:spLocks noGrp="1"/>
-          </p:cNvSpPr>
-          <p:nvPr>
-            <p:ph type="title"/>
-          </p:nvPr>
-        </p:nvSpPr>
-        <p:spPr/>
-        <p:txBody>
-          <a:bodyPr/>
-          <a:lstStyle/>
-          <a:p>
-            <a:r>
-              <a:t>Komplexa ärenden binder resurser</a:t>
-            </a:r>
-          </a:p>
-        </p:txBody>
-      </p:sp>
-      <p:sp>
-        <p:nvSpPr>
-          <p:cNvPr id="3" name="Content Placeholder 2"/>
-          <p:cNvSpPr>
-            <a:spLocks noGrp="1"/>
-          </p:cNvSpPr>
-          <p:nvPr>
-            <p:ph idx="1"/>
-          </p:nvPr>
-        </p:nvSpPr>
-        <p:spPr/>
-        <p:txBody>
-          <a:bodyPr/>
-          <a:lstStyle/>
-          <a:p>
-            <a:r>
-              <a:t>Snitthandläggning: 6,2 dagar</a:t>
-            </a:r>
-          </a:p>
-          <a:p>
-            <a:r>
-              <a:t>4 ärenden står för ca 95 tkr</a:t>
-            </a:r>
-          </a:p>
-          <a:p>
-            <a:r>
-              <a:t>Längre ledtider än snittet</a:t>
-            </a:r>
-          </a:p>
-        </p:txBody>
-      </p:sp>
-    </p:spTree>
-  </p:cSld>
-  <p:clrMapOvr>
-    <a:masterClrMapping/>
-  </p:clrMapOvr>
-</p:sld>
-</file>
-
-<file path=ppt/slides/slide8.xml><?xml version="1.0" encoding="utf-8"?>
-<p:sld xmlns:a="http://schemas.openxmlformats.org/drawingml/2006/main" xmlns:r="http://schemas.openxmlformats.org/officeDocument/2006/relationships" xmlns:p="http://schemas.openxmlformats.org/presentationml/2006/main">
-  <p:cSld>
-    <p:spTree>
-      <p:nvGrpSpPr>
-        <p:cNvPr id="1" name=""/>
-        <p:cNvGrpSpPr/>
-        <p:nvPr/>
-      </p:nvGrpSpPr>
-      <p:grpSpPr>
-        <a:xfrm>
-          <a:off x="0" y="0"/>
-          <a:ext cx="0" cy="0"/>
-          <a:chOff x="0" y="0"/>
-          <a:chExt cx="0" cy="0"/>
-        </a:xfrm>
-      </p:grpSpPr>
-      <p:sp>
-        <p:nvSpPr>
-          <p:cNvPr id="2" name="Title 1"/>
-          <p:cNvSpPr>
-            <a:spLocks noGrp="1"/>
-          </p:cNvSpPr>
-          <p:nvPr>
-            <p:ph type="title"/>
-          </p:nvPr>
-        </p:nvSpPr>
-        <p:spPr/>
-        <p:txBody>
-          <a:bodyPr/>
-          <a:lstStyle/>
-          <a:p>
-            <a:r>
-              <a:t>Fokus framåt – Q2</a:t>
-            </a:r>
-          </a:p>
-        </p:txBody>
-      </p:sp>
-      <p:sp>
-        <p:nvSpPr>
-          <p:cNvPr id="3" name="Content Placeholder 2"/>
-          <p:cNvSpPr>
-            <a:spLocks noGrp="1"/>
-          </p:cNvSpPr>
-          <p:nvPr>
-            <p:ph idx="1"/>
-          </p:nvPr>
-        </p:nvSpPr>
-        <p:spPr/>
-        <p:txBody>
-          <a:bodyPr/>
-          <a:lstStyle/>
-          <a:p>
-            <a:r>
-              <a:t>Följ hästärenden separat</a:t>
-            </a:r>
-          </a:p>
-          <a:p>
-            <a:r>
-              <a:t>Särskild uppföljning av operationer</a:t>
-            </a:r>
-          </a:p>
-          <a:p>
-            <a:r>
-              <a:t>Tydligare hantering av komplexa ärenden</a:t>
+      <p:grpSpPr/>
+      <p:sp>
+        <p:nvSpPr>
+          <p:cNvPr id="2" name="Rectangle 1"/>
+          <p:cNvSpPr/>
+          <p:nvPr/>
+        </p:nvSpPr>
+        <p:spPr>
+          <a:xfrm>
+            <a:off x="0" y="0"/>
+            <a:ext cx="12191695" cy="6858000"/>
+          </a:xfrm>
+          <a:prstGeom prst="rect">
+            <a:avLst/>
+          </a:prstGeom>
+          <a:solidFill>
+            <a:srgbClr val="FAE6D2"/>
+          </a:solidFill>
+          <a:ln>
+            <a:noFill/>
+          </a:ln>
+        </p:spPr>
+        <p:style>
+          <a:lnRef idx="1">
+            <a:schemeClr val="accent1"/>
+          </a:lnRef>
+          <a:fillRef idx="3">
+            <a:schemeClr val="accent1"/>
+          </a:fillRef>
+          <a:effectRef idx="2">
+            <a:schemeClr val="accent1"/>
+          </a:effectRef>
+          <a:fontRef idx="minor">
+            <a:schemeClr val="lt1"/>
+          </a:fontRef>
+        </p:style>
+        <p:txBody>
+          <a:bodyPr rtlCol="0" anchor="ctr"/>
+          <a:lstStyle/>
+          <a:p>
+            <a:pPr algn="ctr"/>
+          </a:p>
+        </p:txBody>
+      </p:sp>
+      <p:sp>
+        <p:nvSpPr>
+          <p:cNvPr id="3" name="Oval 2"/>
+          <p:cNvSpPr/>
+          <p:nvPr/>
+        </p:nvSpPr>
+        <p:spPr>
+          <a:xfrm>
+            <a:off x="9601200" y="4114800"/>
+            <a:ext cx="4114800" cy="4114800"/>
+          </a:xfrm>
+          <a:prstGeom prst="ellipse">
+            <a:avLst/>
+          </a:prstGeom>
+          <a:solidFill>
+            <a:srgbClr val="6FA68B"/>
+          </a:solidFill>
+          <a:ln>
+            <a:noFill/>
+          </a:ln>
+        </p:spPr>
+        <p:style>
+          <a:lnRef idx="1">
+            <a:schemeClr val="accent1"/>
+          </a:lnRef>
+          <a:fillRef idx="3">
+            <a:schemeClr val="accent1"/>
+          </a:fillRef>
+          <a:effectRef idx="2">
+            <a:schemeClr val="accent1"/>
+          </a:effectRef>
+          <a:fontRef idx="minor">
+            <a:schemeClr val="lt1"/>
+          </a:fontRef>
+        </p:style>
+        <p:txBody>
+          <a:bodyPr rtlCol="0" anchor="ctr"/>
+          <a:lstStyle/>
+          <a:p>
+            <a:pPr algn="ctr"/>
+          </a:p>
+        </p:txBody>
+      </p:sp>
+      <p:sp>
+        <p:nvSpPr>
+          <p:cNvPr id="4" name="Oval 3"/>
+          <p:cNvSpPr/>
+          <p:nvPr/>
+        </p:nvSpPr>
+        <p:spPr>
+          <a:xfrm>
+            <a:off x="10515600" y="5029200"/>
+            <a:ext cx="2286000" cy="2286000"/>
+          </a:xfrm>
+          <a:prstGeom prst="ellipse">
+            <a:avLst/>
+          </a:prstGeom>
+          <a:solidFill>
+            <a:srgbClr val="2E5B4F"/>
+          </a:solidFill>
+          <a:ln>
+            <a:noFill/>
+          </a:ln>
+        </p:spPr>
+        <p:style>
+          <a:lnRef idx="1">
+            <a:schemeClr val="accent1"/>
+          </a:lnRef>
+          <a:fillRef idx="3">
+            <a:schemeClr val="accent1"/>
+          </a:fillRef>
+          <a:effectRef idx="2">
+            <a:schemeClr val="accent1"/>
+          </a:effectRef>
+          <a:fontRef idx="minor">
+            <a:schemeClr val="lt1"/>
+          </a:fontRef>
+        </p:style>
+        <p:txBody>
+          <a:bodyPr rtlCol="0" anchor="ctr"/>
+          <a:lstStyle/>
+          <a:p>
+            <a:pPr algn="ctr"/>
+          </a:p>
+        </p:txBody>
+      </p:sp>
+      <p:sp>
+        <p:nvSpPr>
+          <p:cNvPr id="5" name="TextBox 4"/>
+          <p:cNvSpPr txBox="1"/>
+          <p:nvPr/>
+        </p:nvSpPr>
+        <p:spPr>
+          <a:xfrm>
+            <a:off x="822960" y="2377440"/>
+            <a:ext cx="10058400" cy="1371600"/>
+          </a:xfrm>
+          <a:prstGeom prst="rect">
+            <a:avLst/>
+          </a:prstGeom>
+          <a:noFill/>
+        </p:spPr>
+        <p:txBody>
+          <a:bodyPr wrap="square" anchor="t" lIns="0" rIns="0">
+            <a:spAutoFit/>
+          </a:bodyPr>
+          <a:lstStyle/>
+          <a:p>
+            <a:pPr algn="l"/>
+            <a:r>
+              <a:rPr sz="7200" b="1">
+                <a:solidFill>
+                  <a:srgbClr val="2E5B4F"/>
+                </a:solidFill>
+                <a:latin typeface="Calibri"/>
+              </a:rPr>
+              <a:t>Tack!</a:t>
+            </a:r>
+          </a:p>
+        </p:txBody>
+      </p:sp>
+      <p:sp>
+        <p:nvSpPr>
+          <p:cNvPr id="6" name="TextBox 5"/>
+          <p:cNvSpPr txBox="1"/>
+          <p:nvPr/>
+        </p:nvSpPr>
+        <p:spPr>
+          <a:xfrm>
+            <a:off x="822960" y="4114800"/>
+            <a:ext cx="10058400" cy="548640"/>
+          </a:xfrm>
+          <a:prstGeom prst="rect">
+            <a:avLst/>
+          </a:prstGeom>
+          <a:noFill/>
+        </p:spPr>
+        <p:txBody>
+          <a:bodyPr wrap="square" anchor="t" lIns="0" rIns="0">
+            <a:spAutoFit/>
+          </a:bodyPr>
+          <a:lstStyle/>
+          <a:p>
+            <a:pPr algn="l"/>
+            <a:r>
+              <a:rPr sz="2200" b="0">
+                <a:solidFill>
+                  <a:srgbClr val="1A3D33"/>
+                </a:solidFill>
+                <a:latin typeface="Calibri"/>
+              </a:rPr>
+              <a:t>Frågor? Kontakta oss.</a:t>
+            </a:r>
+          </a:p>
+        </p:txBody>
+      </p:sp>
+      <p:sp>
+        <p:nvSpPr>
+          <p:cNvPr id="7" name="TextBox 6"/>
+          <p:cNvSpPr txBox="1"/>
+          <p:nvPr/>
+        </p:nvSpPr>
+        <p:spPr>
+          <a:xfrm>
+            <a:off x="822960" y="5760720"/>
+            <a:ext cx="10058400" cy="365760"/>
+          </a:xfrm>
+          <a:prstGeom prst="rect">
+            <a:avLst/>
+          </a:prstGeom>
+          <a:noFill/>
+        </p:spPr>
+        <p:txBody>
+          <a:bodyPr wrap="square" anchor="t" lIns="0" rIns="0">
+            <a:spAutoFit/>
+          </a:bodyPr>
+          <a:lstStyle/>
+          <a:p>
+            <a:pPr algn="l"/>
+            <a:r>
+              <a:rPr sz="1200" b="0">
+                <a:solidFill>
+                  <a:srgbClr val="333333"/>
+                </a:solidFill>
+                <a:latin typeface="Calibri"/>
+              </a:rPr>
+              <a:t>Sveland Djurförsäkring  •  sveland.se</a:t>
             </a:r>
           </a:p>
         </p:txBody>

</xml_diff>